<commit_message>
Replace B5 placeholder with a recomputed bootstrap consensus tree
stylo's own BCT is unusable on a slide: radial layout with overlapping raw
filenames, and because the run only spans 50-80 MFW the 0.5-consensus
collapses nearly the whole tree into one polytomy. Recompute it instead from
the same W1 profiles the other figures use -- Cosine Delta, 500 bootstrap
replicates over the MFW columns, neighbour-joining per replicate, greedy
majority-rule consensus (27 branches, mean support 0.76) -- and draw it as a
circular cladogram rooted on MBh 6 with leaves in the stratum palette.

Co-Authored-By: Claude Opus 4.8 <noreply@anthropic.com>
</commit_message>
<xml_diff>
--- a/materials/presentation_2026/chronology_stratification.pptx
+++ b/materials/presentation_2026/chronology_stratification.pptx
@@ -2111,7 +2111,7 @@
           <a:p>
             <a:r>
               <a:rPr lang="en-US" dirty="0"/>
-              <a:t>Alternative, non-spatial view of the same distances.</a:t>
+              <a:t>If someone asks for a tree: here it is. Cosine Delta on the same 80 words, 500 bootstrap replicates (the words are resampled with replacement), neighbour-joining per replicate, majority-rule consensus — so every branch on the slide is one that survived in more than half of the replicates. Rooted arbitrarily on MBh 6. It finds the same groups the map does: the epics, Vāyu–Brahmāṇḍa and the old purāṇic core, the Bhāgavata, the Śivapurāṇa. But a tree asserts descent and nesting, and our texts drift into one another instead of branching cleanly — which is why the talk is built on the map, not on this.</a:t>
             </a:r>
             <a:endParaRPr lang="en-US" dirty="0"/>
           </a:p>
@@ -9820,123 +9820,30 @@
           <a:chExt cx="0" cy="0"/>
         </a:xfrm>
       </p:grpSpPr>
-      <p:sp>
-        <p:nvSpPr>
-          <p:cNvPr id="2" name="Text 0"/>
-          <p:cNvSpPr/>
-          <p:nvPr/>
-        </p:nvSpPr>
-        <p:spPr>
-          <a:xfrm>
-            <a:off x="548640" y="292608"/>
-            <a:ext cx="8229600" cy="292608"/>
+      <p:pic>
+        <p:nvPicPr>
+          <p:cNvPr id="2" name="Image 0" descr="/Users/kengo_1/Desktop/stylometric_works/materials/presentation_2026/figures/consensus_tree.png">    </p:cNvPr>
+          <p:cNvPicPr>
+            <a:picLocks noChangeAspect="1"/>
+          </p:cNvPicPr>
+          <p:nvPr/>
+        </p:nvPicPr>
+        <p:blipFill>
+          <a:blip r:embed="rId1"/>
+          <a:stretch>
+            <a:fillRect/>
+          </a:stretch>
+        </p:blipFill>
+        <p:spPr>
+          <a:xfrm>
+            <a:off x="0" y="0"/>
+            <a:ext cx="12161520" cy="6858000"/>
           </a:xfrm>
           <a:prstGeom prst="rect">
             <a:avLst/>
           </a:prstGeom>
-          <a:noFill/>
-          <a:ln/>
-        </p:spPr>
-        <p:txBody>
-          <a:bodyPr wrap="square" lIns="0" tIns="0" rIns="0" bIns="0" rtlCol="0" anchor="ctr"/>
-          <a:lstStyle/>
-          <a:p>
-            <a:pPr indent="0" marL="0">
-              <a:buNone/>
-            </a:pPr>
-            <a:r>
-              <a:rPr lang="en-US" sz="1200" b="1" spc="300" kern="0" dirty="0">
-                <a:solidFill>
-                  <a:srgbClr val="1F5FA8"/>
-                </a:solidFill>
-                <a:latin typeface="Calibri" pitchFamily="34" charset="0"/>
-                <a:ea typeface="Calibri" pitchFamily="34" charset="-122"/>
-                <a:cs typeface="Calibri" pitchFamily="34" charset="-120"/>
-              </a:rPr>
-              <a:t>BACKUP</a:t>
-            </a:r>
-            <a:endParaRPr lang="en-US" sz="1200" dirty="0"/>
-          </a:p>
-        </p:txBody>
-      </p:sp>
-      <p:sp>
-        <p:nvSpPr>
-          <p:cNvPr id="3" name="Text 1"/>
-          <p:cNvSpPr/>
-          <p:nvPr/>
-        </p:nvSpPr>
-        <p:spPr>
-          <a:xfrm>
-            <a:off x="548640" y="566928"/>
-            <a:ext cx="11064240" cy="822960"/>
-          </a:xfrm>
-          <a:prstGeom prst="rect">
-            <a:avLst/>
-          </a:prstGeom>
-          <a:noFill/>
-          <a:ln/>
-        </p:spPr>
-        <p:txBody>
-          <a:bodyPr wrap="square" lIns="0" tIns="0" rIns="0" bIns="0" rtlCol="0" anchor="t"/>
-          <a:lstStyle/>
-          <a:p>
-            <a:pPr indent="0" marL="0">
-              <a:buNone/>
-            </a:pPr>
-            <a:r>
-              <a:rPr lang="en-US" sz="3000" b="1" dirty="0">
-                <a:solidFill>
-                  <a:srgbClr val="222222"/>
-                </a:solidFill>
-                <a:latin typeface="Georgia" pitchFamily="34" charset="0"/>
-                <a:ea typeface="Georgia" pitchFamily="34" charset="-122"/>
-                <a:cs typeface="Georgia" pitchFamily="34" charset="-120"/>
-              </a:rPr>
-              <a:t>Bootstrap consensus tree</a:t>
-            </a:r>
-            <a:endParaRPr lang="en-US" sz="3000" dirty="0"/>
-          </a:p>
-        </p:txBody>
-      </p:sp>
-      <p:sp>
-        <p:nvSpPr>
-          <p:cNvPr id="4" name="Text 2"/>
-          <p:cNvSpPr/>
-          <p:nvPr/>
-        </p:nvSpPr>
-        <p:spPr>
-          <a:xfrm>
-            <a:off x="1371600" y="2926080"/>
-            <a:ext cx="9418320" cy="914400"/>
-          </a:xfrm>
-          <a:prstGeom prst="rect">
-            <a:avLst/>
-          </a:prstGeom>
-          <a:noFill/>
-          <a:ln/>
-        </p:spPr>
-        <p:txBody>
-          <a:bodyPr wrap="square" rtlCol="0" anchor="ctr"/>
-          <a:lstStyle/>
-          <a:p>
-            <a:pPr algn="ctr" indent="0" marL="0">
-              <a:buNone/>
-            </a:pPr>
-            <a:r>
-              <a:rPr lang="en-US" sz="1600" i="1" dirty="0">
-                <a:solidFill>
-                  <a:srgbClr val="777777"/>
-                </a:solidFill>
-                <a:latin typeface="Calibri" pitchFamily="34" charset="0"/>
-                <a:ea typeface="Calibri" pitchFamily="34" charset="-122"/>
-                <a:cs typeface="Calibri" pitchFamily="34" charset="-120"/>
-              </a:rPr>
-              <a:t>[Figure placeholder — regenerate the Cosine Delta consensus tree from ≥ 2026-07-10 runs before including.]</a:t>
-            </a:r>
-            <a:endParaRPr lang="en-US" sz="1600" dirty="0"/>
-          </a:p>
-        </p:txBody>
-      </p:sp>
+        </p:spPr>
+      </p:pic>
     </p:spTree>
   </p:cSld>
   <p:clrMapOvr>

</xml_diff>